<commit_message>
atividade atualização agenda 08
</commit_message>
<xml_diff>
--- a/Agenda 08/JoaoFlavioDiniz_Ag_08_DSI-II.pptx
+++ b/Agenda 08/JoaoFlavioDiniz_Ag_08_DSI-II.pptx
@@ -5,10 +5,23 @@
     <p:sldMasterId id="2147483648" r:id="rId1"/>
   </p:sldMasterIdLst>
   <p:sldIdLst>
-    <p:sldId id="256" r:id="rId2"/>
-    <p:sldId id="259" r:id="rId3"/>
-    <p:sldId id="258" r:id="rId4"/>
-    <p:sldId id="257" r:id="rId5"/>
+    <p:sldId id="259" r:id="rId2"/>
+    <p:sldId id="263" r:id="rId3"/>
+    <p:sldId id="260" r:id="rId4"/>
+    <p:sldId id="262" r:id="rId5"/>
+    <p:sldId id="265" r:id="rId6"/>
+    <p:sldId id="266" r:id="rId7"/>
+    <p:sldId id="267" r:id="rId8"/>
+    <p:sldId id="268" r:id="rId9"/>
+    <p:sldId id="269" r:id="rId10"/>
+    <p:sldId id="270" r:id="rId11"/>
+    <p:sldId id="271" r:id="rId12"/>
+    <p:sldId id="272" r:id="rId13"/>
+    <p:sldId id="273" r:id="rId14"/>
+    <p:sldId id="274" r:id="rId15"/>
+    <p:sldId id="275" r:id="rId16"/>
+    <p:sldId id="276" r:id="rId17"/>
+    <p:sldId id="277" r:id="rId18"/>
   </p:sldIdLst>
   <p:sldSz cx="12192000" cy="6858000"/>
   <p:notesSz cx="6858000" cy="9144000"/>
@@ -3333,36 +3346,6 @@
   <p:cSld>
     <p:spTree>
       <p:nvGrpSpPr>
-        <p:cNvPr id="1" name=""/>
-        <p:cNvGrpSpPr/>
-        <p:nvPr/>
-      </p:nvGrpSpPr>
-      <p:grpSpPr>
-        <a:xfrm>
-          <a:off x="0" y="0"/>
-          <a:ext cx="0" cy="0"/>
-          <a:chOff x="0" y="0"/>
-          <a:chExt cx="0" cy="0"/>
-        </a:xfrm>
-      </p:grpSpPr>
-    </p:spTree>
-    <p:extLst>
-      <p:ext uri="{BB962C8B-B14F-4D97-AF65-F5344CB8AC3E}">
-        <p14:creationId xmlns:p14="http://schemas.microsoft.com/office/powerpoint/2010/main" val="180910073"/>
-      </p:ext>
-    </p:extLst>
-  </p:cSld>
-  <p:clrMapOvr>
-    <a:masterClrMapping/>
-  </p:clrMapOvr>
-</p:sld>
-</file>
-
-<file path=ppt/slides/slide2.xml><?xml version="1.0" encoding="utf-8"?>
-<p:sld xmlns:a="http://schemas.openxmlformats.org/drawingml/2006/main" xmlns:r="http://schemas.openxmlformats.org/officeDocument/2006/relationships" xmlns:p="http://schemas.openxmlformats.org/presentationml/2006/main">
-  <p:cSld>
-    <p:spTree>
-      <p:nvGrpSpPr>
         <p:cNvPr id="1" name="">
           <a:extLst>
             <a:ext uri="{FF2B5EF4-FFF2-40B4-BE49-F238E27FC236}">
@@ -3425,8 +3408,8 @@
         </p:nvSpPr>
         <p:spPr>
           <a:xfrm>
-            <a:off x="2601686" y="587829"/>
-            <a:ext cx="6081152" cy="523220"/>
+            <a:off x="4049486" y="502104"/>
+            <a:ext cx="3086229" cy="523220"/>
           </a:xfrm>
           <a:prstGeom prst="rect">
             <a:avLst/>
@@ -3441,13 +3424,8 @@
           <a:p>
             <a:r>
               <a:rPr lang="pt-BR" sz="2800" dirty="0"/>
-              <a:t>Tela de apresentação inicial </a:t>
-            </a:r>
-            <a:r>
-              <a:rPr lang="pt-BR" sz="2800" dirty="0" err="1"/>
-              <a:t>index.php</a:t>
-            </a:r>
-            <a:endParaRPr lang="pt-BR" sz="2800" dirty="0"/>
+              <a:t>Tela de login inicial</a:t>
+            </a:r>
           </a:p>
         </p:txBody>
       </p:sp>
@@ -3455,6 +3433,906 @@
     <p:extLst>
       <p:ext uri="{BB962C8B-B14F-4D97-AF65-F5344CB8AC3E}">
         <p14:creationId xmlns:p14="http://schemas.microsoft.com/office/powerpoint/2010/main" val="1223555642"/>
+      </p:ext>
+    </p:extLst>
+  </p:cSld>
+  <p:clrMapOvr>
+    <a:masterClrMapping/>
+  </p:clrMapOvr>
+</p:sld>
+</file>
+
+<file path=ppt/slides/slide10.xml><?xml version="1.0" encoding="utf-8"?>
+<p:sld xmlns:a="http://schemas.openxmlformats.org/drawingml/2006/main" xmlns:r="http://schemas.openxmlformats.org/officeDocument/2006/relationships" xmlns:p="http://schemas.openxmlformats.org/presentationml/2006/main">
+  <p:cSld>
+    <p:spTree>
+      <p:nvGrpSpPr>
+        <p:cNvPr id="1" name="">
+          <a:extLst>
+            <a:ext uri="{FF2B5EF4-FFF2-40B4-BE49-F238E27FC236}">
+              <a16:creationId xmlns:a16="http://schemas.microsoft.com/office/drawing/2014/main" id="{DBEA12BF-1E03-37CF-C07B-EEA5F2ECC565}"/>
+            </a:ext>
+          </a:extLst>
+        </p:cNvPr>
+        <p:cNvGrpSpPr/>
+        <p:nvPr/>
+      </p:nvGrpSpPr>
+      <p:grpSpPr>
+        <a:xfrm>
+          <a:off x="0" y="0"/>
+          <a:ext cx="0" cy="0"/>
+          <a:chOff x="0" y="0"/>
+          <a:chExt cx="0" cy="0"/>
+        </a:xfrm>
+      </p:grpSpPr>
+      <p:pic>
+        <p:nvPicPr>
+          <p:cNvPr id="2" name="Imagem 1">
+            <a:extLst>
+              <a:ext uri="{FF2B5EF4-FFF2-40B4-BE49-F238E27FC236}">
+                <a16:creationId xmlns:a16="http://schemas.microsoft.com/office/drawing/2014/main" id="{930AA1FD-FC3F-EE9E-53AC-D84EE66E30FC}"/>
+              </a:ext>
+            </a:extLst>
+          </p:cNvPr>
+          <p:cNvPicPr>
+            <a:picLocks noChangeAspect="1"/>
+          </p:cNvPicPr>
+          <p:nvPr/>
+        </p:nvPicPr>
+        <p:blipFill>
+          <a:blip r:embed="rId2"/>
+          <a:stretch>
+            <a:fillRect/>
+          </a:stretch>
+        </p:blipFill>
+        <p:spPr>
+          <a:xfrm>
+            <a:off x="1076814" y="1534160"/>
+            <a:ext cx="9876936" cy="4527316"/>
+          </a:xfrm>
+          <a:prstGeom prst="rect">
+            <a:avLst/>
+          </a:prstGeom>
+        </p:spPr>
+      </p:pic>
+      <p:sp>
+        <p:nvSpPr>
+          <p:cNvPr id="4" name="CaixaDeTexto 3">
+            <a:extLst>
+              <a:ext uri="{FF2B5EF4-FFF2-40B4-BE49-F238E27FC236}">
+                <a16:creationId xmlns:a16="http://schemas.microsoft.com/office/drawing/2014/main" id="{C4D73D59-7433-6BC3-C9E5-ECA9F9EF85E9}"/>
+              </a:ext>
+            </a:extLst>
+          </p:cNvPr>
+          <p:cNvSpPr txBox="1"/>
+          <p:nvPr/>
+        </p:nvSpPr>
+        <p:spPr>
+          <a:xfrm>
+            <a:off x="2973161" y="664029"/>
+            <a:ext cx="5440272" cy="523220"/>
+          </a:xfrm>
+          <a:prstGeom prst="rect">
+            <a:avLst/>
+          </a:prstGeom>
+          <a:noFill/>
+        </p:spPr>
+        <p:txBody>
+          <a:bodyPr wrap="none" rtlCol="0">
+            <a:spAutoFit/>
+          </a:bodyPr>
+          <a:lstStyle/>
+          <a:p>
+            <a:r>
+              <a:rPr lang="pt-BR" sz="2800" dirty="0"/>
+              <a:t>Exemplo de alteração de cadastro</a:t>
+            </a:r>
+          </a:p>
+        </p:txBody>
+      </p:sp>
+    </p:spTree>
+    <p:extLst>
+      <p:ext uri="{BB962C8B-B14F-4D97-AF65-F5344CB8AC3E}">
+        <p14:creationId xmlns:p14="http://schemas.microsoft.com/office/powerpoint/2010/main" val="1161083002"/>
+      </p:ext>
+    </p:extLst>
+  </p:cSld>
+  <p:clrMapOvr>
+    <a:masterClrMapping/>
+  </p:clrMapOvr>
+</p:sld>
+</file>
+
+<file path=ppt/slides/slide11.xml><?xml version="1.0" encoding="utf-8"?>
+<p:sld xmlns:a="http://schemas.openxmlformats.org/drawingml/2006/main" xmlns:r="http://schemas.openxmlformats.org/officeDocument/2006/relationships" xmlns:p="http://schemas.openxmlformats.org/presentationml/2006/main">
+  <p:cSld>
+    <p:spTree>
+      <p:nvGrpSpPr>
+        <p:cNvPr id="1" name="">
+          <a:extLst>
+            <a:ext uri="{FF2B5EF4-FFF2-40B4-BE49-F238E27FC236}">
+              <a16:creationId xmlns:a16="http://schemas.microsoft.com/office/drawing/2014/main" id="{2FCEF91C-D82B-6BB2-BFC1-900CCBB7C566}"/>
+            </a:ext>
+          </a:extLst>
+        </p:cNvPr>
+        <p:cNvGrpSpPr/>
+        <p:nvPr/>
+      </p:nvGrpSpPr>
+      <p:grpSpPr>
+        <a:xfrm>
+          <a:off x="0" y="0"/>
+          <a:ext cx="0" cy="0"/>
+          <a:chOff x="0" y="0"/>
+          <a:chExt cx="0" cy="0"/>
+        </a:xfrm>
+      </p:grpSpPr>
+      <p:pic>
+        <p:nvPicPr>
+          <p:cNvPr id="2" name="Imagem 1">
+            <a:extLst>
+              <a:ext uri="{FF2B5EF4-FFF2-40B4-BE49-F238E27FC236}">
+                <a16:creationId xmlns:a16="http://schemas.microsoft.com/office/drawing/2014/main" id="{3FC3120E-7875-70A6-2094-E414C1428824}"/>
+              </a:ext>
+            </a:extLst>
+          </p:cNvPr>
+          <p:cNvPicPr>
+            <a:picLocks noChangeAspect="1"/>
+          </p:cNvPicPr>
+          <p:nvPr/>
+        </p:nvPicPr>
+        <p:blipFill>
+          <a:blip r:embed="rId2"/>
+          <a:stretch>
+            <a:fillRect/>
+          </a:stretch>
+        </p:blipFill>
+        <p:spPr>
+          <a:xfrm>
+            <a:off x="1664079" y="2446655"/>
+            <a:ext cx="9608441" cy="3563620"/>
+          </a:xfrm>
+          <a:prstGeom prst="rect">
+            <a:avLst/>
+          </a:prstGeom>
+        </p:spPr>
+      </p:pic>
+      <p:sp>
+        <p:nvSpPr>
+          <p:cNvPr id="4" name="CaixaDeTexto 3">
+            <a:extLst>
+              <a:ext uri="{FF2B5EF4-FFF2-40B4-BE49-F238E27FC236}">
+                <a16:creationId xmlns:a16="http://schemas.microsoft.com/office/drawing/2014/main" id="{51BCBC2D-D4DD-1CD1-4478-D8693B193072}"/>
+              </a:ext>
+            </a:extLst>
+          </p:cNvPr>
+          <p:cNvSpPr txBox="1"/>
+          <p:nvPr/>
+        </p:nvSpPr>
+        <p:spPr>
+          <a:xfrm>
+            <a:off x="3020786" y="1035504"/>
+            <a:ext cx="5835700" cy="523220"/>
+          </a:xfrm>
+          <a:prstGeom prst="rect">
+            <a:avLst/>
+          </a:prstGeom>
+          <a:noFill/>
+        </p:spPr>
+        <p:txBody>
+          <a:bodyPr wrap="none" rtlCol="0">
+            <a:spAutoFit/>
+          </a:bodyPr>
+          <a:lstStyle/>
+          <a:p>
+            <a:r>
+              <a:rPr lang="pt-BR" sz="2800" dirty="0"/>
+              <a:t>Mensagem de sucesso de alteração!</a:t>
+            </a:r>
+          </a:p>
+        </p:txBody>
+      </p:sp>
+    </p:spTree>
+    <p:extLst>
+      <p:ext uri="{BB962C8B-B14F-4D97-AF65-F5344CB8AC3E}">
+        <p14:creationId xmlns:p14="http://schemas.microsoft.com/office/powerpoint/2010/main" val="2086851615"/>
+      </p:ext>
+    </p:extLst>
+  </p:cSld>
+  <p:clrMapOvr>
+    <a:masterClrMapping/>
+  </p:clrMapOvr>
+</p:sld>
+</file>
+
+<file path=ppt/slides/slide12.xml><?xml version="1.0" encoding="utf-8"?>
+<p:sld xmlns:a="http://schemas.openxmlformats.org/drawingml/2006/main" xmlns:r="http://schemas.openxmlformats.org/officeDocument/2006/relationships" xmlns:p="http://schemas.openxmlformats.org/presentationml/2006/main">
+  <p:cSld>
+    <p:spTree>
+      <p:nvGrpSpPr>
+        <p:cNvPr id="1" name="">
+          <a:extLst>
+            <a:ext uri="{FF2B5EF4-FFF2-40B4-BE49-F238E27FC236}">
+              <a16:creationId xmlns:a16="http://schemas.microsoft.com/office/drawing/2014/main" id="{8575427D-0E58-1694-C393-69A8146D7645}"/>
+            </a:ext>
+          </a:extLst>
+        </p:cNvPr>
+        <p:cNvGrpSpPr/>
+        <p:nvPr/>
+      </p:nvGrpSpPr>
+      <p:grpSpPr>
+        <a:xfrm>
+          <a:off x="0" y="0"/>
+          <a:ext cx="0" cy="0"/>
+          <a:chOff x="0" y="0"/>
+          <a:chExt cx="0" cy="0"/>
+        </a:xfrm>
+      </p:grpSpPr>
+      <p:pic>
+        <p:nvPicPr>
+          <p:cNvPr id="2" name="Imagem 1">
+            <a:extLst>
+              <a:ext uri="{FF2B5EF4-FFF2-40B4-BE49-F238E27FC236}">
+                <a16:creationId xmlns:a16="http://schemas.microsoft.com/office/drawing/2014/main" id="{48E06722-0C34-80A2-8E30-F4045FBA9D11}"/>
+              </a:ext>
+            </a:extLst>
+          </p:cNvPr>
+          <p:cNvPicPr>
+            <a:picLocks noChangeAspect="1"/>
+          </p:cNvPicPr>
+          <p:nvPr/>
+        </p:nvPicPr>
+        <p:blipFill>
+          <a:blip r:embed="rId2"/>
+          <a:stretch>
+            <a:fillRect/>
+          </a:stretch>
+        </p:blipFill>
+        <p:spPr>
+          <a:xfrm>
+            <a:off x="486947" y="2359341"/>
+            <a:ext cx="11599106" cy="3574733"/>
+          </a:xfrm>
+          <a:prstGeom prst="rect">
+            <a:avLst/>
+          </a:prstGeom>
+        </p:spPr>
+      </p:pic>
+      <p:sp>
+        <p:nvSpPr>
+          <p:cNvPr id="4" name="CaixaDeTexto 3">
+            <a:extLst>
+              <a:ext uri="{FF2B5EF4-FFF2-40B4-BE49-F238E27FC236}">
+                <a16:creationId xmlns:a16="http://schemas.microsoft.com/office/drawing/2014/main" id="{4325F649-3E19-400C-E258-B35D6B9488E0}"/>
+              </a:ext>
+            </a:extLst>
+          </p:cNvPr>
+          <p:cNvSpPr txBox="1"/>
+          <p:nvPr/>
+        </p:nvSpPr>
+        <p:spPr>
+          <a:xfrm>
+            <a:off x="1868261" y="1149804"/>
+            <a:ext cx="9002849" cy="523220"/>
+          </a:xfrm>
+          <a:prstGeom prst="rect">
+            <a:avLst/>
+          </a:prstGeom>
+          <a:noFill/>
+        </p:spPr>
+        <p:txBody>
+          <a:bodyPr wrap="none" rtlCol="0">
+            <a:spAutoFit/>
+          </a:bodyPr>
+          <a:lstStyle/>
+          <a:p>
+            <a:r>
+              <a:rPr lang="pt-BR" sz="2800" dirty="0"/>
+              <a:t>Confirmação de alteração das informações no cadastro</a:t>
+            </a:r>
+          </a:p>
+        </p:txBody>
+      </p:sp>
+    </p:spTree>
+    <p:extLst>
+      <p:ext uri="{BB962C8B-B14F-4D97-AF65-F5344CB8AC3E}">
+        <p14:creationId xmlns:p14="http://schemas.microsoft.com/office/powerpoint/2010/main" val="1740627882"/>
+      </p:ext>
+    </p:extLst>
+  </p:cSld>
+  <p:clrMapOvr>
+    <a:masterClrMapping/>
+  </p:clrMapOvr>
+</p:sld>
+</file>
+
+<file path=ppt/slides/slide13.xml><?xml version="1.0" encoding="utf-8"?>
+<p:sld xmlns:a="http://schemas.openxmlformats.org/drawingml/2006/main" xmlns:r="http://schemas.openxmlformats.org/officeDocument/2006/relationships" xmlns:p="http://schemas.openxmlformats.org/presentationml/2006/main">
+  <p:cSld>
+    <p:spTree>
+      <p:nvGrpSpPr>
+        <p:cNvPr id="1" name="">
+          <a:extLst>
+            <a:ext uri="{FF2B5EF4-FFF2-40B4-BE49-F238E27FC236}">
+              <a16:creationId xmlns:a16="http://schemas.microsoft.com/office/drawing/2014/main" id="{9ECB782B-0516-6072-3BD8-A23F49DCADA6}"/>
+            </a:ext>
+          </a:extLst>
+        </p:cNvPr>
+        <p:cNvGrpSpPr/>
+        <p:nvPr/>
+      </p:nvGrpSpPr>
+      <p:grpSpPr>
+        <a:xfrm>
+          <a:off x="0" y="0"/>
+          <a:ext cx="0" cy="0"/>
+          <a:chOff x="0" y="0"/>
+          <a:chExt cx="0" cy="0"/>
+        </a:xfrm>
+      </p:grpSpPr>
+      <p:pic>
+        <p:nvPicPr>
+          <p:cNvPr id="2" name="Imagem 1">
+            <a:extLst>
+              <a:ext uri="{FF2B5EF4-FFF2-40B4-BE49-F238E27FC236}">
+                <a16:creationId xmlns:a16="http://schemas.microsoft.com/office/drawing/2014/main" id="{82C9C81A-09A7-5BE8-5C1E-552D03A5F3E8}"/>
+              </a:ext>
+            </a:extLst>
+          </p:cNvPr>
+          <p:cNvPicPr>
+            <a:picLocks noChangeAspect="1"/>
+          </p:cNvPicPr>
+          <p:nvPr/>
+        </p:nvPicPr>
+        <p:blipFill>
+          <a:blip r:embed="rId2"/>
+          <a:stretch>
+            <a:fillRect/>
+          </a:stretch>
+        </p:blipFill>
+        <p:spPr>
+          <a:xfrm>
+            <a:off x="1585331" y="1880416"/>
+            <a:ext cx="9309298" cy="4199255"/>
+          </a:xfrm>
+          <a:prstGeom prst="rect">
+            <a:avLst/>
+          </a:prstGeom>
+        </p:spPr>
+      </p:pic>
+      <p:sp>
+        <p:nvSpPr>
+          <p:cNvPr id="4" name="CaixaDeTexto 3">
+            <a:extLst>
+              <a:ext uri="{FF2B5EF4-FFF2-40B4-BE49-F238E27FC236}">
+                <a16:creationId xmlns:a16="http://schemas.microsoft.com/office/drawing/2014/main" id="{4ADE5825-86B4-9EAA-E1B0-25AE37498DF6}"/>
+              </a:ext>
+            </a:extLst>
+          </p:cNvPr>
+          <p:cNvSpPr txBox="1"/>
+          <p:nvPr/>
+        </p:nvSpPr>
+        <p:spPr>
+          <a:xfrm>
+            <a:off x="641045" y="778329"/>
+            <a:ext cx="10909910" cy="523220"/>
+          </a:xfrm>
+          <a:prstGeom prst="rect">
+            <a:avLst/>
+          </a:prstGeom>
+          <a:noFill/>
+        </p:spPr>
+        <p:txBody>
+          <a:bodyPr wrap="none" rtlCol="0">
+            <a:spAutoFit/>
+          </a:bodyPr>
+          <a:lstStyle/>
+          <a:p>
+            <a:r>
+              <a:rPr lang="pt-BR" sz="2800" dirty="0"/>
+              <a:t>Tela de exclusão de amigos com opção de cancelamento de exclusão</a:t>
+            </a:r>
+          </a:p>
+        </p:txBody>
+      </p:sp>
+    </p:spTree>
+    <p:extLst>
+      <p:ext uri="{BB962C8B-B14F-4D97-AF65-F5344CB8AC3E}">
+        <p14:creationId xmlns:p14="http://schemas.microsoft.com/office/powerpoint/2010/main" val="1876285282"/>
+      </p:ext>
+    </p:extLst>
+  </p:cSld>
+  <p:clrMapOvr>
+    <a:masterClrMapping/>
+  </p:clrMapOvr>
+</p:sld>
+</file>
+
+<file path=ppt/slides/slide14.xml><?xml version="1.0" encoding="utf-8"?>
+<p:sld xmlns:a="http://schemas.openxmlformats.org/drawingml/2006/main" xmlns:r="http://schemas.openxmlformats.org/officeDocument/2006/relationships" xmlns:p="http://schemas.openxmlformats.org/presentationml/2006/main">
+  <p:cSld>
+    <p:spTree>
+      <p:nvGrpSpPr>
+        <p:cNvPr id="1" name="">
+          <a:extLst>
+            <a:ext uri="{FF2B5EF4-FFF2-40B4-BE49-F238E27FC236}">
+              <a16:creationId xmlns:a16="http://schemas.microsoft.com/office/drawing/2014/main" id="{C6A35D9D-08D5-BB61-D8D4-72439E57B4A1}"/>
+            </a:ext>
+          </a:extLst>
+        </p:cNvPr>
+        <p:cNvGrpSpPr/>
+        <p:nvPr/>
+      </p:nvGrpSpPr>
+      <p:grpSpPr>
+        <a:xfrm>
+          <a:off x="0" y="0"/>
+          <a:ext cx="0" cy="0"/>
+          <a:chOff x="0" y="0"/>
+          <a:chExt cx="0" cy="0"/>
+        </a:xfrm>
+      </p:grpSpPr>
+      <p:pic>
+        <p:nvPicPr>
+          <p:cNvPr id="2" name="Imagem 1">
+            <a:extLst>
+              <a:ext uri="{FF2B5EF4-FFF2-40B4-BE49-F238E27FC236}">
+                <a16:creationId xmlns:a16="http://schemas.microsoft.com/office/drawing/2014/main" id="{38A8F1DE-B16A-40A9-DD7E-3F514BE32137}"/>
+              </a:ext>
+            </a:extLst>
+          </p:cNvPr>
+          <p:cNvPicPr>
+            <a:picLocks noChangeAspect="1"/>
+          </p:cNvPicPr>
+          <p:nvPr/>
+        </p:nvPicPr>
+        <p:blipFill>
+          <a:blip r:embed="rId2"/>
+          <a:stretch>
+            <a:fillRect/>
+          </a:stretch>
+        </p:blipFill>
+        <p:spPr>
+          <a:xfrm>
+            <a:off x="746127" y="2232977"/>
+            <a:ext cx="10699746" cy="3758248"/>
+          </a:xfrm>
+          <a:prstGeom prst="rect">
+            <a:avLst/>
+          </a:prstGeom>
+        </p:spPr>
+      </p:pic>
+      <p:sp>
+        <p:nvSpPr>
+          <p:cNvPr id="4" name="CaixaDeTexto 3">
+            <a:extLst>
+              <a:ext uri="{FF2B5EF4-FFF2-40B4-BE49-F238E27FC236}">
+                <a16:creationId xmlns:a16="http://schemas.microsoft.com/office/drawing/2014/main" id="{A2A362A8-4446-FA1F-3F90-03453B6145AE}"/>
+              </a:ext>
+            </a:extLst>
+          </p:cNvPr>
+          <p:cNvSpPr txBox="1"/>
+          <p:nvPr/>
+        </p:nvSpPr>
+        <p:spPr>
+          <a:xfrm>
+            <a:off x="2735036" y="866775"/>
+            <a:ext cx="5755678" cy="523220"/>
+          </a:xfrm>
+          <a:prstGeom prst="rect">
+            <a:avLst/>
+          </a:prstGeom>
+          <a:noFill/>
+        </p:spPr>
+        <p:txBody>
+          <a:bodyPr wrap="none" rtlCol="0">
+            <a:spAutoFit/>
+          </a:bodyPr>
+          <a:lstStyle/>
+          <a:p>
+            <a:r>
+              <a:rPr lang="pt-BR" sz="2800" dirty="0"/>
+              <a:t>Mensagem de sucesso de exclusão!</a:t>
+            </a:r>
+          </a:p>
+        </p:txBody>
+      </p:sp>
+    </p:spTree>
+    <p:extLst>
+      <p:ext uri="{BB962C8B-B14F-4D97-AF65-F5344CB8AC3E}">
+        <p14:creationId xmlns:p14="http://schemas.microsoft.com/office/powerpoint/2010/main" val="1146437359"/>
+      </p:ext>
+    </p:extLst>
+  </p:cSld>
+  <p:clrMapOvr>
+    <a:masterClrMapping/>
+  </p:clrMapOvr>
+</p:sld>
+</file>
+
+<file path=ppt/slides/slide15.xml><?xml version="1.0" encoding="utf-8"?>
+<p:sld xmlns:a="http://schemas.openxmlformats.org/drawingml/2006/main" xmlns:r="http://schemas.openxmlformats.org/officeDocument/2006/relationships" xmlns:p="http://schemas.openxmlformats.org/presentationml/2006/main">
+  <p:cSld>
+    <p:spTree>
+      <p:nvGrpSpPr>
+        <p:cNvPr id="1" name="">
+          <a:extLst>
+            <a:ext uri="{FF2B5EF4-FFF2-40B4-BE49-F238E27FC236}">
+              <a16:creationId xmlns:a16="http://schemas.microsoft.com/office/drawing/2014/main" id="{F291B091-D47F-56BF-8CA9-5FFBD8E97BBB}"/>
+            </a:ext>
+          </a:extLst>
+        </p:cNvPr>
+        <p:cNvGrpSpPr/>
+        <p:nvPr/>
+      </p:nvGrpSpPr>
+      <p:grpSpPr>
+        <a:xfrm>
+          <a:off x="0" y="0"/>
+          <a:ext cx="0" cy="0"/>
+          <a:chOff x="0" y="0"/>
+          <a:chExt cx="0" cy="0"/>
+        </a:xfrm>
+      </p:grpSpPr>
+      <p:pic>
+        <p:nvPicPr>
+          <p:cNvPr id="2" name="Imagem 1">
+            <a:extLst>
+              <a:ext uri="{FF2B5EF4-FFF2-40B4-BE49-F238E27FC236}">
+                <a16:creationId xmlns:a16="http://schemas.microsoft.com/office/drawing/2014/main" id="{26D02A8E-3389-28AE-C7B4-03143CDFA2BA}"/>
+              </a:ext>
+            </a:extLst>
+          </p:cNvPr>
+          <p:cNvPicPr>
+            <a:picLocks noChangeAspect="1"/>
+          </p:cNvPicPr>
+          <p:nvPr/>
+        </p:nvPicPr>
+        <p:blipFill>
+          <a:blip r:embed="rId2"/>
+          <a:stretch>
+            <a:fillRect/>
+          </a:stretch>
+        </p:blipFill>
+        <p:spPr>
+          <a:xfrm>
+            <a:off x="592554" y="2479357"/>
+            <a:ext cx="11254541" cy="3397568"/>
+          </a:xfrm>
+          <a:prstGeom prst="rect">
+            <a:avLst/>
+          </a:prstGeom>
+        </p:spPr>
+      </p:pic>
+      <p:sp>
+        <p:nvSpPr>
+          <p:cNvPr id="4" name="CaixaDeTexto 3">
+            <a:extLst>
+              <a:ext uri="{FF2B5EF4-FFF2-40B4-BE49-F238E27FC236}">
+                <a16:creationId xmlns:a16="http://schemas.microsoft.com/office/drawing/2014/main" id="{96DC6FFC-8E78-EEF2-3A33-0BA65F972BDE}"/>
+              </a:ext>
+            </a:extLst>
+          </p:cNvPr>
+          <p:cNvSpPr txBox="1"/>
+          <p:nvPr/>
+        </p:nvSpPr>
+        <p:spPr>
+          <a:xfrm>
+            <a:off x="1949319" y="1178379"/>
+            <a:ext cx="8293361" cy="523220"/>
+          </a:xfrm>
+          <a:prstGeom prst="rect">
+            <a:avLst/>
+          </a:prstGeom>
+          <a:noFill/>
+        </p:spPr>
+        <p:txBody>
+          <a:bodyPr wrap="none" rtlCol="0">
+            <a:spAutoFit/>
+          </a:bodyPr>
+          <a:lstStyle/>
+          <a:p>
+            <a:r>
+              <a:rPr lang="pt-BR" sz="2800" dirty="0"/>
+              <a:t>Tela de listagem de amigos, confirmando a alteração</a:t>
+            </a:r>
+          </a:p>
+        </p:txBody>
+      </p:sp>
+    </p:spTree>
+    <p:extLst>
+      <p:ext uri="{BB962C8B-B14F-4D97-AF65-F5344CB8AC3E}">
+        <p14:creationId xmlns:p14="http://schemas.microsoft.com/office/powerpoint/2010/main" val="3122604312"/>
+      </p:ext>
+    </p:extLst>
+  </p:cSld>
+  <p:clrMapOvr>
+    <a:masterClrMapping/>
+  </p:clrMapOvr>
+</p:sld>
+</file>
+
+<file path=ppt/slides/slide16.xml><?xml version="1.0" encoding="utf-8"?>
+<p:sld xmlns:a="http://schemas.openxmlformats.org/drawingml/2006/main" xmlns:r="http://schemas.openxmlformats.org/officeDocument/2006/relationships" xmlns:p="http://schemas.openxmlformats.org/presentationml/2006/main">
+  <p:cSld>
+    <p:spTree>
+      <p:nvGrpSpPr>
+        <p:cNvPr id="1" name="">
+          <a:extLst>
+            <a:ext uri="{FF2B5EF4-FFF2-40B4-BE49-F238E27FC236}">
+              <a16:creationId xmlns:a16="http://schemas.microsoft.com/office/drawing/2014/main" id="{F36BB5D9-19A4-8C37-E903-2BEB2133D5F2}"/>
+            </a:ext>
+          </a:extLst>
+        </p:cNvPr>
+        <p:cNvGrpSpPr/>
+        <p:nvPr/>
+      </p:nvGrpSpPr>
+      <p:grpSpPr>
+        <a:xfrm>
+          <a:off x="0" y="0"/>
+          <a:ext cx="0" cy="0"/>
+          <a:chOff x="0" y="0"/>
+          <a:chExt cx="0" cy="0"/>
+        </a:xfrm>
+      </p:grpSpPr>
+      <p:pic>
+        <p:nvPicPr>
+          <p:cNvPr id="2" name="Imagem 1">
+            <a:extLst>
+              <a:ext uri="{FF2B5EF4-FFF2-40B4-BE49-F238E27FC236}">
+                <a16:creationId xmlns:a16="http://schemas.microsoft.com/office/drawing/2014/main" id="{7E4884CA-F024-2785-C337-02F7B439F464}"/>
+              </a:ext>
+            </a:extLst>
+          </p:cNvPr>
+          <p:cNvPicPr>
+            <a:picLocks noChangeAspect="1"/>
+          </p:cNvPicPr>
+          <p:nvPr/>
+        </p:nvPicPr>
+        <p:blipFill>
+          <a:blip r:embed="rId2"/>
+          <a:stretch>
+            <a:fillRect/>
+          </a:stretch>
+        </p:blipFill>
+        <p:spPr>
+          <a:xfrm>
+            <a:off x="718569" y="1564957"/>
+            <a:ext cx="10754862" cy="4541475"/>
+          </a:xfrm>
+          <a:prstGeom prst="rect">
+            <a:avLst/>
+          </a:prstGeom>
+        </p:spPr>
+      </p:pic>
+      <p:sp>
+        <p:nvSpPr>
+          <p:cNvPr id="4" name="CaixaDeTexto 3">
+            <a:extLst>
+              <a:ext uri="{FF2B5EF4-FFF2-40B4-BE49-F238E27FC236}">
+                <a16:creationId xmlns:a16="http://schemas.microsoft.com/office/drawing/2014/main" id="{05EB199F-817C-730E-B646-BE8C34B18AB1}"/>
+              </a:ext>
+            </a:extLst>
+          </p:cNvPr>
+          <p:cNvSpPr txBox="1"/>
+          <p:nvPr/>
+        </p:nvSpPr>
+        <p:spPr>
+          <a:xfrm>
+            <a:off x="2077811" y="606879"/>
+            <a:ext cx="7813101" cy="523220"/>
+          </a:xfrm>
+          <a:prstGeom prst="rect">
+            <a:avLst/>
+          </a:prstGeom>
+          <a:noFill/>
+        </p:spPr>
+        <p:txBody>
+          <a:bodyPr wrap="none" rtlCol="0">
+            <a:spAutoFit/>
+          </a:bodyPr>
+          <a:lstStyle/>
+          <a:p>
+            <a:r>
+              <a:rPr lang="pt-BR" sz="2800" dirty="0"/>
+              <a:t>Tela de apresentação inicial com opção de logout</a:t>
+            </a:r>
+          </a:p>
+        </p:txBody>
+      </p:sp>
+    </p:spTree>
+    <p:extLst>
+      <p:ext uri="{BB962C8B-B14F-4D97-AF65-F5344CB8AC3E}">
+        <p14:creationId xmlns:p14="http://schemas.microsoft.com/office/powerpoint/2010/main" val="519175957"/>
+      </p:ext>
+    </p:extLst>
+  </p:cSld>
+  <p:clrMapOvr>
+    <a:masterClrMapping/>
+  </p:clrMapOvr>
+</p:sld>
+</file>
+
+<file path=ppt/slides/slide17.xml><?xml version="1.0" encoding="utf-8"?>
+<p:sld xmlns:a="http://schemas.openxmlformats.org/drawingml/2006/main" xmlns:r="http://schemas.openxmlformats.org/officeDocument/2006/relationships" xmlns:p="http://schemas.openxmlformats.org/presentationml/2006/main">
+  <p:cSld>
+    <p:spTree>
+      <p:nvGrpSpPr>
+        <p:cNvPr id="1" name="">
+          <a:extLst>
+            <a:ext uri="{FF2B5EF4-FFF2-40B4-BE49-F238E27FC236}">
+              <a16:creationId xmlns:a16="http://schemas.microsoft.com/office/drawing/2014/main" id="{B7284AC3-C4A2-7E05-93BF-567920281A7E}"/>
+            </a:ext>
+          </a:extLst>
+        </p:cNvPr>
+        <p:cNvGrpSpPr/>
+        <p:nvPr/>
+      </p:nvGrpSpPr>
+      <p:grpSpPr>
+        <a:xfrm>
+          <a:off x="0" y="0"/>
+          <a:ext cx="0" cy="0"/>
+          <a:chOff x="0" y="0"/>
+          <a:chExt cx="0" cy="0"/>
+        </a:xfrm>
+      </p:grpSpPr>
+      <p:sp>
+        <p:nvSpPr>
+          <p:cNvPr id="4" name="CaixaDeTexto 3">
+            <a:extLst>
+              <a:ext uri="{FF2B5EF4-FFF2-40B4-BE49-F238E27FC236}">
+                <a16:creationId xmlns:a16="http://schemas.microsoft.com/office/drawing/2014/main" id="{CDBF530C-E207-31F2-7ED7-A72E5C3CDA41}"/>
+              </a:ext>
+            </a:extLst>
+          </p:cNvPr>
+          <p:cNvSpPr txBox="1"/>
+          <p:nvPr/>
+        </p:nvSpPr>
+        <p:spPr>
+          <a:xfrm>
+            <a:off x="3077936" y="2924830"/>
+            <a:ext cx="5467009" cy="646331"/>
+          </a:xfrm>
+          <a:prstGeom prst="rect">
+            <a:avLst/>
+          </a:prstGeom>
+          <a:noFill/>
+        </p:spPr>
+        <p:txBody>
+          <a:bodyPr wrap="none" rtlCol="0">
+            <a:spAutoFit/>
+          </a:bodyPr>
+          <a:lstStyle/>
+          <a:p>
+            <a:r>
+              <a:rPr lang="pt-BR" sz="3600" dirty="0"/>
+              <a:t>Obrigado por sua atenção!</a:t>
+            </a:r>
+          </a:p>
+        </p:txBody>
+      </p:sp>
+    </p:spTree>
+    <p:extLst>
+      <p:ext uri="{BB962C8B-B14F-4D97-AF65-F5344CB8AC3E}">
+        <p14:creationId xmlns:p14="http://schemas.microsoft.com/office/powerpoint/2010/main" val="2864771532"/>
+      </p:ext>
+    </p:extLst>
+  </p:cSld>
+  <p:clrMapOvr>
+    <a:masterClrMapping/>
+  </p:clrMapOvr>
+</p:sld>
+</file>
+
+<file path=ppt/slides/slide2.xml><?xml version="1.0" encoding="utf-8"?>
+<p:sld xmlns:a="http://schemas.openxmlformats.org/drawingml/2006/main" xmlns:r="http://schemas.openxmlformats.org/officeDocument/2006/relationships" xmlns:p="http://schemas.openxmlformats.org/presentationml/2006/main">
+  <p:cSld>
+    <p:spTree>
+      <p:nvGrpSpPr>
+        <p:cNvPr id="1" name="">
+          <a:extLst>
+            <a:ext uri="{FF2B5EF4-FFF2-40B4-BE49-F238E27FC236}">
+              <a16:creationId xmlns:a16="http://schemas.microsoft.com/office/drawing/2014/main" id="{2185A846-E4FA-723E-42F9-4D4938A2D4B9}"/>
+            </a:ext>
+          </a:extLst>
+        </p:cNvPr>
+        <p:cNvGrpSpPr/>
+        <p:nvPr/>
+      </p:nvGrpSpPr>
+      <p:grpSpPr>
+        <a:xfrm>
+          <a:off x="0" y="0"/>
+          <a:ext cx="0" cy="0"/>
+          <a:chOff x="0" y="0"/>
+          <a:chExt cx="0" cy="0"/>
+        </a:xfrm>
+      </p:grpSpPr>
+      <p:pic>
+        <p:nvPicPr>
+          <p:cNvPr id="3" name="Imagem 2">
+            <a:extLst>
+              <a:ext uri="{FF2B5EF4-FFF2-40B4-BE49-F238E27FC236}">
+                <a16:creationId xmlns:a16="http://schemas.microsoft.com/office/drawing/2014/main" id="{545FFAB9-56BF-E2C3-3DE5-B09C5E27DDAD}"/>
+              </a:ext>
+            </a:extLst>
+          </p:cNvPr>
+          <p:cNvPicPr>
+            <a:picLocks noChangeAspect="1"/>
+          </p:cNvPicPr>
+          <p:nvPr/>
+        </p:nvPicPr>
+        <p:blipFill>
+          <a:blip r:embed="rId2"/>
+          <a:stretch>
+            <a:fillRect/>
+          </a:stretch>
+        </p:blipFill>
+        <p:spPr>
+          <a:xfrm>
+            <a:off x="1016575" y="1943101"/>
+            <a:ext cx="10158847" cy="4375150"/>
+          </a:xfrm>
+          <a:prstGeom prst="rect">
+            <a:avLst/>
+          </a:prstGeom>
+        </p:spPr>
+      </p:pic>
+      <p:sp>
+        <p:nvSpPr>
+          <p:cNvPr id="4" name="CaixaDeTexto 3">
+            <a:extLst>
+              <a:ext uri="{FF2B5EF4-FFF2-40B4-BE49-F238E27FC236}">
+                <a16:creationId xmlns:a16="http://schemas.microsoft.com/office/drawing/2014/main" id="{D7EDE17B-E3D1-6E86-5045-011C7DDCB0C3}"/>
+              </a:ext>
+            </a:extLst>
+          </p:cNvPr>
+          <p:cNvSpPr txBox="1"/>
+          <p:nvPr/>
+        </p:nvSpPr>
+        <p:spPr>
+          <a:xfrm>
+            <a:off x="2222919" y="1162050"/>
+            <a:ext cx="7746160" cy="369332"/>
+          </a:xfrm>
+          <a:prstGeom prst="rect">
+            <a:avLst/>
+          </a:prstGeom>
+          <a:noFill/>
+        </p:spPr>
+        <p:txBody>
+          <a:bodyPr wrap="none" rtlCol="0">
+            <a:spAutoFit/>
+          </a:bodyPr>
+          <a:lstStyle/>
+          <a:p>
+            <a:r>
+              <a:rPr lang="pt-BR" dirty="0"/>
+              <a:t>Código da página inicial </a:t>
+            </a:r>
+            <a:r>
+              <a:rPr lang="pt-BR" dirty="0" err="1"/>
+              <a:t>index.php</a:t>
+            </a:r>
+            <a:r>
+              <a:rPr lang="pt-BR" dirty="0"/>
+              <a:t>, </a:t>
+            </a:r>
+            <a:r>
+              <a:rPr lang="pt-BR" dirty="0" err="1"/>
+              <a:t>inclusão.php</a:t>
+            </a:r>
+            <a:r>
+              <a:rPr lang="pt-BR" dirty="0"/>
+              <a:t> de cabeçalho e </a:t>
+            </a:r>
+            <a:r>
+              <a:rPr lang="pt-BR" dirty="0" err="1"/>
+              <a:t>rodapé.php</a:t>
+            </a:r>
+            <a:endParaRPr lang="pt-BR" dirty="0"/>
+          </a:p>
+        </p:txBody>
+      </p:sp>
+    </p:spTree>
+    <p:extLst>
+      <p:ext uri="{BB962C8B-B14F-4D97-AF65-F5344CB8AC3E}">
+        <p14:creationId xmlns:p14="http://schemas.microsoft.com/office/powerpoint/2010/main" val="4058123197"/>
       </p:ext>
     </p:extLst>
   </p:cSld>
@@ -3472,7 +4350,309 @@
         <p:cNvPr id="1" name="">
           <a:extLst>
             <a:ext uri="{FF2B5EF4-FFF2-40B4-BE49-F238E27FC236}">
-              <a16:creationId xmlns:a16="http://schemas.microsoft.com/office/drawing/2014/main" id="{53D290C1-5DE4-6C65-0574-B671D1EBDF65}"/>
+              <a16:creationId xmlns:a16="http://schemas.microsoft.com/office/drawing/2014/main" id="{404CFDCF-26AF-5A79-B2A0-F1DBA7E842EB}"/>
+            </a:ext>
+          </a:extLst>
+        </p:cNvPr>
+        <p:cNvGrpSpPr/>
+        <p:nvPr/>
+      </p:nvGrpSpPr>
+      <p:grpSpPr>
+        <a:xfrm>
+          <a:off x="0" y="0"/>
+          <a:ext cx="0" cy="0"/>
+          <a:chOff x="0" y="0"/>
+          <a:chExt cx="0" cy="0"/>
+        </a:xfrm>
+      </p:grpSpPr>
+      <p:pic>
+        <p:nvPicPr>
+          <p:cNvPr id="2" name="Imagem 1">
+            <a:extLst>
+              <a:ext uri="{FF2B5EF4-FFF2-40B4-BE49-F238E27FC236}">
+                <a16:creationId xmlns:a16="http://schemas.microsoft.com/office/drawing/2014/main" id="{00FDAF60-F00C-1A41-49BB-0FD6C6EC93F2}"/>
+              </a:ext>
+            </a:extLst>
+          </p:cNvPr>
+          <p:cNvPicPr>
+            <a:picLocks noChangeAspect="1"/>
+          </p:cNvPicPr>
+          <p:nvPr/>
+        </p:nvPicPr>
+        <p:blipFill>
+          <a:blip r:embed="rId2"/>
+          <a:stretch>
+            <a:fillRect/>
+          </a:stretch>
+        </p:blipFill>
+        <p:spPr>
+          <a:xfrm>
+            <a:off x="3158368" y="536540"/>
+            <a:ext cx="8027913" cy="2755583"/>
+          </a:xfrm>
+          <a:prstGeom prst="rect">
+            <a:avLst/>
+          </a:prstGeom>
+        </p:spPr>
+      </p:pic>
+      <p:pic>
+        <p:nvPicPr>
+          <p:cNvPr id="6" name="Imagem 5">
+            <a:extLst>
+              <a:ext uri="{FF2B5EF4-FFF2-40B4-BE49-F238E27FC236}">
+                <a16:creationId xmlns:a16="http://schemas.microsoft.com/office/drawing/2014/main" id="{9DCDA9E0-5903-E3DF-454F-2A065B1569B6}"/>
+              </a:ext>
+            </a:extLst>
+          </p:cNvPr>
+          <p:cNvPicPr>
+            <a:picLocks noChangeAspect="1"/>
+          </p:cNvPicPr>
+          <p:nvPr/>
+        </p:nvPicPr>
+        <p:blipFill>
+          <a:blip r:embed="rId3"/>
+          <a:stretch>
+            <a:fillRect/>
+          </a:stretch>
+        </p:blipFill>
+        <p:spPr>
+          <a:xfrm>
+            <a:off x="3750322" y="3474268"/>
+            <a:ext cx="6706033" cy="3383732"/>
+          </a:xfrm>
+          <a:prstGeom prst="rect">
+            <a:avLst/>
+          </a:prstGeom>
+        </p:spPr>
+      </p:pic>
+      <p:sp>
+        <p:nvSpPr>
+          <p:cNvPr id="7" name="CaixaDeTexto 6">
+            <a:extLst>
+              <a:ext uri="{FF2B5EF4-FFF2-40B4-BE49-F238E27FC236}">
+                <a16:creationId xmlns:a16="http://schemas.microsoft.com/office/drawing/2014/main" id="{B72AF855-F809-B050-166A-5294640F2C2F}"/>
+              </a:ext>
+            </a:extLst>
+          </p:cNvPr>
+          <p:cNvSpPr txBox="1"/>
+          <p:nvPr/>
+        </p:nvSpPr>
+        <p:spPr>
+          <a:xfrm>
+            <a:off x="439790" y="1466850"/>
+            <a:ext cx="4001545" cy="1384995"/>
+          </a:xfrm>
+          <a:prstGeom prst="rect">
+            <a:avLst/>
+          </a:prstGeom>
+          <a:noFill/>
+        </p:spPr>
+        <p:txBody>
+          <a:bodyPr wrap="none" rtlCol="0">
+            <a:spAutoFit/>
+          </a:bodyPr>
+          <a:lstStyle/>
+          <a:p>
+            <a:pPr algn="just"/>
+            <a:r>
+              <a:rPr lang="pt-BR" sz="2800" dirty="0"/>
+              <a:t>Tela de sucesso de login </a:t>
+            </a:r>
+          </a:p>
+          <a:p>
+            <a:pPr algn="just"/>
+            <a:r>
+              <a:rPr lang="pt-BR" sz="2800" dirty="0"/>
+              <a:t>Caso o usuário</a:t>
+            </a:r>
+          </a:p>
+          <a:p>
+            <a:pPr algn="just"/>
+            <a:r>
+              <a:rPr lang="pt-BR" sz="2800" dirty="0"/>
+              <a:t> estejam corretos. </a:t>
+            </a:r>
+          </a:p>
+        </p:txBody>
+      </p:sp>
+      <p:sp>
+        <p:nvSpPr>
+          <p:cNvPr id="9" name="CaixaDeTexto 8">
+            <a:extLst>
+              <a:ext uri="{FF2B5EF4-FFF2-40B4-BE49-F238E27FC236}">
+                <a16:creationId xmlns:a16="http://schemas.microsoft.com/office/drawing/2014/main" id="{2EA84BE0-E809-052C-0E53-8BD1BE7D2B10}"/>
+              </a:ext>
+            </a:extLst>
+          </p:cNvPr>
+          <p:cNvSpPr txBox="1"/>
+          <p:nvPr/>
+        </p:nvSpPr>
+        <p:spPr>
+          <a:xfrm>
+            <a:off x="754652" y="4591050"/>
+            <a:ext cx="3371820" cy="1384995"/>
+          </a:xfrm>
+          <a:prstGeom prst="rect">
+            <a:avLst/>
+          </a:prstGeom>
+          <a:noFill/>
+        </p:spPr>
+        <p:txBody>
+          <a:bodyPr wrap="none" rtlCol="0">
+            <a:spAutoFit/>
+          </a:bodyPr>
+          <a:lstStyle/>
+          <a:p>
+            <a:pPr algn="just"/>
+            <a:r>
+              <a:rPr lang="pt-BR" sz="2800" dirty="0"/>
+              <a:t>Tela de login inválido</a:t>
+            </a:r>
+          </a:p>
+          <a:p>
+            <a:pPr algn="just"/>
+            <a:r>
+              <a:rPr lang="pt-BR" sz="2800" dirty="0"/>
+              <a:t>Caso o usuário</a:t>
+            </a:r>
+          </a:p>
+          <a:p>
+            <a:pPr algn="just"/>
+            <a:r>
+              <a:rPr lang="pt-BR" sz="2800" dirty="0"/>
+              <a:t> estejam errados. </a:t>
+            </a:r>
+          </a:p>
+        </p:txBody>
+      </p:sp>
+    </p:spTree>
+    <p:extLst>
+      <p:ext uri="{BB962C8B-B14F-4D97-AF65-F5344CB8AC3E}">
+        <p14:creationId xmlns:p14="http://schemas.microsoft.com/office/powerpoint/2010/main" val="101962035"/>
+      </p:ext>
+    </p:extLst>
+  </p:cSld>
+  <p:clrMapOvr>
+    <a:masterClrMapping/>
+  </p:clrMapOvr>
+</p:sld>
+</file>
+
+<file path=ppt/slides/slide4.xml><?xml version="1.0" encoding="utf-8"?>
+<p:sld xmlns:a="http://schemas.openxmlformats.org/drawingml/2006/main" xmlns:r="http://schemas.openxmlformats.org/officeDocument/2006/relationships" xmlns:p="http://schemas.openxmlformats.org/presentationml/2006/main">
+  <p:cSld>
+    <p:spTree>
+      <p:nvGrpSpPr>
+        <p:cNvPr id="1" name="">
+          <a:extLst>
+            <a:ext uri="{FF2B5EF4-FFF2-40B4-BE49-F238E27FC236}">
+              <a16:creationId xmlns:a16="http://schemas.microsoft.com/office/drawing/2014/main" id="{147E4DA8-74CC-3282-5446-1F36AA4284E2}"/>
+            </a:ext>
+          </a:extLst>
+        </p:cNvPr>
+        <p:cNvGrpSpPr/>
+        <p:nvPr/>
+      </p:nvGrpSpPr>
+      <p:grpSpPr>
+        <a:xfrm>
+          <a:off x="0" y="0"/>
+          <a:ext cx="0" cy="0"/>
+          <a:chOff x="0" y="0"/>
+          <a:chExt cx="0" cy="0"/>
+        </a:xfrm>
+      </p:grpSpPr>
+      <p:pic>
+        <p:nvPicPr>
+          <p:cNvPr id="2" name="Imagem 1">
+            <a:extLst>
+              <a:ext uri="{FF2B5EF4-FFF2-40B4-BE49-F238E27FC236}">
+                <a16:creationId xmlns:a16="http://schemas.microsoft.com/office/drawing/2014/main" id="{C22923C5-BC7F-FBB8-43FE-A837630A11A9}"/>
+              </a:ext>
+            </a:extLst>
+          </p:cNvPr>
+          <p:cNvPicPr>
+            <a:picLocks noChangeAspect="1"/>
+          </p:cNvPicPr>
+          <p:nvPr/>
+        </p:nvPicPr>
+        <p:blipFill>
+          <a:blip r:embed="rId2"/>
+          <a:stretch>
+            <a:fillRect/>
+          </a:stretch>
+        </p:blipFill>
+        <p:spPr>
+          <a:xfrm>
+            <a:off x="1194705" y="1555114"/>
+            <a:ext cx="10011140" cy="4617085"/>
+          </a:xfrm>
+          <a:prstGeom prst="rect">
+            <a:avLst/>
+          </a:prstGeom>
+        </p:spPr>
+      </p:pic>
+      <p:sp>
+        <p:nvSpPr>
+          <p:cNvPr id="5" name="CaixaDeTexto 4">
+            <a:extLst>
+              <a:ext uri="{FF2B5EF4-FFF2-40B4-BE49-F238E27FC236}">
+                <a16:creationId xmlns:a16="http://schemas.microsoft.com/office/drawing/2014/main" id="{5BF51A84-D55C-3137-E6A4-7617CBE9E95C}"/>
+              </a:ext>
+            </a:extLst>
+          </p:cNvPr>
+          <p:cNvSpPr txBox="1"/>
+          <p:nvPr/>
+        </p:nvSpPr>
+        <p:spPr>
+          <a:xfrm>
+            <a:off x="2601686" y="587829"/>
+            <a:ext cx="6081152" cy="523220"/>
+          </a:xfrm>
+          <a:prstGeom prst="rect">
+            <a:avLst/>
+          </a:prstGeom>
+          <a:noFill/>
+        </p:spPr>
+        <p:txBody>
+          <a:bodyPr wrap="none" rtlCol="0">
+            <a:spAutoFit/>
+          </a:bodyPr>
+          <a:lstStyle/>
+          <a:p>
+            <a:r>
+              <a:rPr lang="pt-BR" sz="2800" dirty="0"/>
+              <a:t>Tela de apresentação inicial </a:t>
+            </a:r>
+            <a:r>
+              <a:rPr lang="pt-BR" sz="2800" dirty="0" err="1"/>
+              <a:t>index.php</a:t>
+            </a:r>
+            <a:endParaRPr lang="pt-BR" sz="2800" dirty="0"/>
+          </a:p>
+        </p:txBody>
+      </p:sp>
+    </p:spTree>
+    <p:extLst>
+      <p:ext uri="{BB962C8B-B14F-4D97-AF65-F5344CB8AC3E}">
+        <p14:creationId xmlns:p14="http://schemas.microsoft.com/office/powerpoint/2010/main" val="2873241362"/>
+      </p:ext>
+    </p:extLst>
+  </p:cSld>
+  <p:clrMapOvr>
+    <a:masterClrMapping/>
+  </p:clrMapOvr>
+</p:sld>
+</file>
+
+<file path=ppt/slides/slide5.xml><?xml version="1.0" encoding="utf-8"?>
+<p:sld xmlns:a="http://schemas.openxmlformats.org/drawingml/2006/main" xmlns:r="http://schemas.openxmlformats.org/officeDocument/2006/relationships" xmlns:p="http://schemas.openxmlformats.org/presentationml/2006/main">
+  <p:cSld>
+    <p:spTree>
+      <p:nvGrpSpPr>
+        <p:cNvPr id="1" name="">
+          <a:extLst>
+            <a:ext uri="{FF2B5EF4-FFF2-40B4-BE49-F238E27FC236}">
+              <a16:creationId xmlns:a16="http://schemas.microsoft.com/office/drawing/2014/main" id="{BFEA52BF-6C03-2062-0843-39CB89DB4AAC}"/>
             </a:ext>
           </a:extLst>
         </p:cNvPr>
@@ -3492,7 +4672,7 @@
           <p:cNvPr id="3" name="Imagem 2">
             <a:extLst>
               <a:ext uri="{FF2B5EF4-FFF2-40B4-BE49-F238E27FC236}">
-                <a16:creationId xmlns:a16="http://schemas.microsoft.com/office/drawing/2014/main" id="{53EDB604-1891-709C-3D6B-3C747C95347A}"/>
+                <a16:creationId xmlns:a16="http://schemas.microsoft.com/office/drawing/2014/main" id="{73DF9579-F5AD-2C49-5343-16ABCC8258C4}"/>
               </a:ext>
             </a:extLst>
           </p:cNvPr>
@@ -3509,8 +4689,8 @@
         </p:blipFill>
         <p:spPr>
           <a:xfrm>
-            <a:off x="4187937" y="173946"/>
-            <a:ext cx="7808121" cy="6684054"/>
+            <a:off x="1447800" y="1451609"/>
+            <a:ext cx="9296400" cy="5313543"/>
           </a:xfrm>
           <a:prstGeom prst="rect">
             <a:avLst/>
@@ -3519,10 +4699,10 @@
       </p:pic>
       <p:sp>
         <p:nvSpPr>
-          <p:cNvPr id="4" name="CaixaDeTexto 3">
-            <a:extLst>
-              <a:ext uri="{FF2B5EF4-FFF2-40B4-BE49-F238E27FC236}">
-                <a16:creationId xmlns:a16="http://schemas.microsoft.com/office/drawing/2014/main" id="{C819C948-43B0-2E33-CCED-F29639649D0F}"/>
+          <p:cNvPr id="5" name="CaixaDeTexto 4">
+            <a:extLst>
+              <a:ext uri="{FF2B5EF4-FFF2-40B4-BE49-F238E27FC236}">
+                <a16:creationId xmlns:a16="http://schemas.microsoft.com/office/drawing/2014/main" id="{16A90E25-5AE6-0080-2B89-B323215EFF55}"/>
               </a:ext>
             </a:extLst>
           </p:cNvPr>
@@ -3531,8 +4711,8 @@
         </p:nvSpPr>
         <p:spPr>
           <a:xfrm>
-            <a:off x="1023257" y="1730829"/>
-            <a:ext cx="680636" cy="369332"/>
+            <a:off x="1939285" y="597354"/>
+            <a:ext cx="8313430" cy="523220"/>
           </a:xfrm>
           <a:prstGeom prst="rect">
             <a:avLst/>
@@ -3546,8 +4726,8 @@
           <a:lstStyle/>
           <a:p>
             <a:r>
-              <a:rPr lang="pt-BR" dirty="0"/>
-              <a:t>texto</a:t>
+              <a:rPr lang="pt-BR" sz="2800" dirty="0"/>
+              <a:t>Descrição do login e conexão com o banco de dados</a:t>
             </a:r>
           </a:p>
         </p:txBody>
@@ -3555,7 +4735,7 @@
     </p:spTree>
     <p:extLst>
       <p:ext uri="{BB962C8B-B14F-4D97-AF65-F5344CB8AC3E}">
-        <p14:creationId xmlns:p14="http://schemas.microsoft.com/office/powerpoint/2010/main" val="1281222837"/>
+        <p14:creationId xmlns:p14="http://schemas.microsoft.com/office/powerpoint/2010/main" val="3092578130"/>
       </p:ext>
     </p:extLst>
   </p:cSld>
@@ -3565,12 +4745,18 @@
 </p:sld>
 </file>
 
-<file path=ppt/slides/slide4.xml><?xml version="1.0" encoding="utf-8"?>
+<file path=ppt/slides/slide6.xml><?xml version="1.0" encoding="utf-8"?>
 <p:sld xmlns:a="http://schemas.openxmlformats.org/drawingml/2006/main" xmlns:r="http://schemas.openxmlformats.org/officeDocument/2006/relationships" xmlns:p="http://schemas.openxmlformats.org/presentationml/2006/main">
   <p:cSld>
     <p:spTree>
       <p:nvGrpSpPr>
-        <p:cNvPr id="1" name=""/>
+        <p:cNvPr id="1" name="">
+          <a:extLst>
+            <a:ext uri="{FF2B5EF4-FFF2-40B4-BE49-F238E27FC236}">
+              <a16:creationId xmlns:a16="http://schemas.microsoft.com/office/drawing/2014/main" id="{366F1EAA-8043-DA78-07B4-E05C22F8C25F}"/>
+            </a:ext>
+          </a:extLst>
+        </p:cNvPr>
         <p:cNvGrpSpPr/>
         <p:nvPr/>
       </p:nvGrpSpPr>
@@ -3582,60 +4768,386 @@
           <a:chExt cx="0" cy="0"/>
         </a:xfrm>
       </p:grpSpPr>
-      <p:sp>
-        <p:nvSpPr>
-          <p:cNvPr id="2" name="Título 1">
-            <a:extLst>
-              <a:ext uri="{FF2B5EF4-FFF2-40B4-BE49-F238E27FC236}">
-                <a16:creationId xmlns:a16="http://schemas.microsoft.com/office/drawing/2014/main" id="{CB4906B2-EAD9-F540-27E6-7F0B5E952E55}"/>
-              </a:ext>
-            </a:extLst>
-          </p:cNvPr>
-          <p:cNvSpPr>
-            <a:spLocks noGrp="1"/>
-          </p:cNvSpPr>
-          <p:nvPr>
-            <p:ph type="title"/>
-          </p:nvPr>
-        </p:nvSpPr>
-        <p:spPr/>
-        <p:txBody>
-          <a:bodyPr/>
-          <a:lstStyle/>
-          <a:p>
-            <a:endParaRPr lang="pt-BR"/>
-          </a:p>
-        </p:txBody>
-      </p:sp>
-      <p:sp>
-        <p:nvSpPr>
-          <p:cNvPr id="3" name="Marcador de Posição de Conteúdo 2">
-            <a:extLst>
-              <a:ext uri="{FF2B5EF4-FFF2-40B4-BE49-F238E27FC236}">
-                <a16:creationId xmlns:a16="http://schemas.microsoft.com/office/drawing/2014/main" id="{BF453B03-F82A-625E-9FAF-6C23FA0A164D}"/>
-              </a:ext>
-            </a:extLst>
-          </p:cNvPr>
-          <p:cNvSpPr>
-            <a:spLocks noGrp="1"/>
-          </p:cNvSpPr>
-          <p:nvPr>
-            <p:ph idx="1"/>
-          </p:nvPr>
-        </p:nvSpPr>
-        <p:spPr/>
-        <p:txBody>
-          <a:bodyPr/>
-          <a:lstStyle/>
-          <a:p>
-            <a:endParaRPr lang="pt-BR"/>
+      <p:pic>
+        <p:nvPicPr>
+          <p:cNvPr id="3" name="Imagem 2">
+            <a:extLst>
+              <a:ext uri="{FF2B5EF4-FFF2-40B4-BE49-F238E27FC236}">
+                <a16:creationId xmlns:a16="http://schemas.microsoft.com/office/drawing/2014/main" id="{95E49E6C-3F04-A1E6-D0DA-4E1D6FA3EE10}"/>
+              </a:ext>
+            </a:extLst>
+          </p:cNvPr>
+          <p:cNvPicPr>
+            <a:picLocks noChangeAspect="1"/>
+          </p:cNvPicPr>
+          <p:nvPr/>
+        </p:nvPicPr>
+        <p:blipFill>
+          <a:blip r:embed="rId2"/>
+          <a:stretch>
+            <a:fillRect/>
+          </a:stretch>
+        </p:blipFill>
+        <p:spPr>
+          <a:xfrm>
+            <a:off x="813105" y="1812290"/>
+            <a:ext cx="10565790" cy="4550410"/>
+          </a:xfrm>
+          <a:prstGeom prst="rect">
+            <a:avLst/>
+          </a:prstGeom>
+        </p:spPr>
+      </p:pic>
+      <p:sp>
+        <p:nvSpPr>
+          <p:cNvPr id="5" name="CaixaDeTexto 4">
+            <a:extLst>
+              <a:ext uri="{FF2B5EF4-FFF2-40B4-BE49-F238E27FC236}">
+                <a16:creationId xmlns:a16="http://schemas.microsoft.com/office/drawing/2014/main" id="{CBB239D6-9429-DC1A-8F50-6F2304980DB7}"/>
+              </a:ext>
+            </a:extLst>
+          </p:cNvPr>
+          <p:cNvSpPr txBox="1"/>
+          <p:nvPr/>
+        </p:nvSpPr>
+        <p:spPr>
+          <a:xfrm>
+            <a:off x="834431" y="921204"/>
+            <a:ext cx="10523137" cy="523220"/>
+          </a:xfrm>
+          <a:prstGeom prst="rect">
+            <a:avLst/>
+          </a:prstGeom>
+          <a:noFill/>
+        </p:spPr>
+        <p:txBody>
+          <a:bodyPr wrap="none" rtlCol="0">
+            <a:spAutoFit/>
+          </a:bodyPr>
+          <a:lstStyle/>
+          <a:p>
+            <a:r>
+              <a:rPr lang="pt-BR" sz="2800" dirty="0"/>
+              <a:t>Inclusão de cabeçalho e rodapé usando o </a:t>
+            </a:r>
+            <a:r>
+              <a:rPr lang="pt-BR" sz="2800" dirty="0" err="1"/>
+              <a:t>php</a:t>
+            </a:r>
+            <a:r>
+              <a:rPr lang="pt-BR" sz="2800" dirty="0"/>
+              <a:t>, redução de códigos</a:t>
+            </a:r>
           </a:p>
         </p:txBody>
       </p:sp>
     </p:spTree>
     <p:extLst>
       <p:ext uri="{BB962C8B-B14F-4D97-AF65-F5344CB8AC3E}">
-        <p14:creationId xmlns:p14="http://schemas.microsoft.com/office/powerpoint/2010/main" val="166975247"/>
+        <p14:creationId xmlns:p14="http://schemas.microsoft.com/office/powerpoint/2010/main" val="2237135763"/>
+      </p:ext>
+    </p:extLst>
+  </p:cSld>
+  <p:clrMapOvr>
+    <a:masterClrMapping/>
+  </p:clrMapOvr>
+</p:sld>
+</file>
+
+<file path=ppt/slides/slide7.xml><?xml version="1.0" encoding="utf-8"?>
+<p:sld xmlns:a="http://schemas.openxmlformats.org/drawingml/2006/main" xmlns:r="http://schemas.openxmlformats.org/officeDocument/2006/relationships" xmlns:p="http://schemas.openxmlformats.org/presentationml/2006/main">
+  <p:cSld>
+    <p:spTree>
+      <p:nvGrpSpPr>
+        <p:cNvPr id="1" name="">
+          <a:extLst>
+            <a:ext uri="{FF2B5EF4-FFF2-40B4-BE49-F238E27FC236}">
+              <a16:creationId xmlns:a16="http://schemas.microsoft.com/office/drawing/2014/main" id="{914DA0E8-5B2D-8F7E-2480-5887F4EE69E3}"/>
+            </a:ext>
+          </a:extLst>
+        </p:cNvPr>
+        <p:cNvGrpSpPr/>
+        <p:nvPr/>
+      </p:nvGrpSpPr>
+      <p:grpSpPr>
+        <a:xfrm>
+          <a:off x="0" y="0"/>
+          <a:ext cx="0" cy="0"/>
+          <a:chOff x="0" y="0"/>
+          <a:chExt cx="0" cy="0"/>
+        </a:xfrm>
+      </p:grpSpPr>
+      <p:pic>
+        <p:nvPicPr>
+          <p:cNvPr id="2" name="Imagem 1">
+            <a:extLst>
+              <a:ext uri="{FF2B5EF4-FFF2-40B4-BE49-F238E27FC236}">
+                <a16:creationId xmlns:a16="http://schemas.microsoft.com/office/drawing/2014/main" id="{27991887-8B7A-A09E-0532-D61C6000750E}"/>
+              </a:ext>
+            </a:extLst>
+          </p:cNvPr>
+          <p:cNvPicPr>
+            <a:picLocks noChangeAspect="1"/>
+          </p:cNvPicPr>
+          <p:nvPr/>
+        </p:nvPicPr>
+        <p:blipFill>
+          <a:blip r:embed="rId2"/>
+          <a:stretch>
+            <a:fillRect/>
+          </a:stretch>
+        </p:blipFill>
+        <p:spPr>
+          <a:xfrm>
+            <a:off x="1184209" y="1429384"/>
+            <a:ext cx="9823581" cy="4638526"/>
+          </a:xfrm>
+          <a:prstGeom prst="rect">
+            <a:avLst/>
+          </a:prstGeom>
+        </p:spPr>
+      </p:pic>
+      <p:sp>
+        <p:nvSpPr>
+          <p:cNvPr id="4" name="CaixaDeTexto 3">
+            <a:extLst>
+              <a:ext uri="{FF2B5EF4-FFF2-40B4-BE49-F238E27FC236}">
+                <a16:creationId xmlns:a16="http://schemas.microsoft.com/office/drawing/2014/main" id="{7766A2C7-7B02-8AAE-C14D-ADDBF3738589}"/>
+              </a:ext>
+            </a:extLst>
+          </p:cNvPr>
+          <p:cNvSpPr txBox="1"/>
+          <p:nvPr/>
+        </p:nvSpPr>
+        <p:spPr>
+          <a:xfrm>
+            <a:off x="3497036" y="616404"/>
+            <a:ext cx="4377673" cy="523220"/>
+          </a:xfrm>
+          <a:prstGeom prst="rect">
+            <a:avLst/>
+          </a:prstGeom>
+          <a:noFill/>
+        </p:spPr>
+        <p:txBody>
+          <a:bodyPr wrap="none" rtlCol="0">
+            <a:spAutoFit/>
+          </a:bodyPr>
+          <a:lstStyle/>
+          <a:p>
+            <a:r>
+              <a:rPr lang="pt-BR" sz="2800" dirty="0"/>
+              <a:t>Tela de cadastro de amigos</a:t>
+            </a:r>
+          </a:p>
+        </p:txBody>
+      </p:sp>
+    </p:spTree>
+    <p:extLst>
+      <p:ext uri="{BB962C8B-B14F-4D97-AF65-F5344CB8AC3E}">
+        <p14:creationId xmlns:p14="http://schemas.microsoft.com/office/powerpoint/2010/main" val="2910600461"/>
+      </p:ext>
+    </p:extLst>
+  </p:cSld>
+  <p:clrMapOvr>
+    <a:masterClrMapping/>
+  </p:clrMapOvr>
+</p:sld>
+</file>
+
+<file path=ppt/slides/slide8.xml><?xml version="1.0" encoding="utf-8"?>
+<p:sld xmlns:a="http://schemas.openxmlformats.org/drawingml/2006/main" xmlns:r="http://schemas.openxmlformats.org/officeDocument/2006/relationships" xmlns:p="http://schemas.openxmlformats.org/presentationml/2006/main">
+  <p:cSld>
+    <p:spTree>
+      <p:nvGrpSpPr>
+        <p:cNvPr id="1" name="">
+          <a:extLst>
+            <a:ext uri="{FF2B5EF4-FFF2-40B4-BE49-F238E27FC236}">
+              <a16:creationId xmlns:a16="http://schemas.microsoft.com/office/drawing/2014/main" id="{42A621DC-DDA9-F84C-E6F8-37034437B949}"/>
+            </a:ext>
+          </a:extLst>
+        </p:cNvPr>
+        <p:cNvGrpSpPr/>
+        <p:nvPr/>
+      </p:nvGrpSpPr>
+      <p:grpSpPr>
+        <a:xfrm>
+          <a:off x="0" y="0"/>
+          <a:ext cx="0" cy="0"/>
+          <a:chOff x="0" y="0"/>
+          <a:chExt cx="0" cy="0"/>
+        </a:xfrm>
+      </p:grpSpPr>
+      <p:pic>
+        <p:nvPicPr>
+          <p:cNvPr id="2" name="Imagem 1">
+            <a:extLst>
+              <a:ext uri="{FF2B5EF4-FFF2-40B4-BE49-F238E27FC236}">
+                <a16:creationId xmlns:a16="http://schemas.microsoft.com/office/drawing/2014/main" id="{3E7E6CE3-CC3A-49BB-1A1A-9335ECFDDC79}"/>
+              </a:ext>
+            </a:extLst>
+          </p:cNvPr>
+          <p:cNvPicPr>
+            <a:picLocks noChangeAspect="1"/>
+          </p:cNvPicPr>
+          <p:nvPr/>
+        </p:nvPicPr>
+        <p:blipFill>
+          <a:blip r:embed="rId2"/>
+          <a:stretch>
+            <a:fillRect/>
+          </a:stretch>
+        </p:blipFill>
+        <p:spPr>
+          <a:xfrm>
+            <a:off x="662791" y="2009456"/>
+            <a:ext cx="10572649" cy="4029393"/>
+          </a:xfrm>
+          <a:prstGeom prst="rect">
+            <a:avLst/>
+          </a:prstGeom>
+        </p:spPr>
+      </p:pic>
+      <p:sp>
+        <p:nvSpPr>
+          <p:cNvPr id="4" name="CaixaDeTexto 3">
+            <a:extLst>
+              <a:ext uri="{FF2B5EF4-FFF2-40B4-BE49-F238E27FC236}">
+                <a16:creationId xmlns:a16="http://schemas.microsoft.com/office/drawing/2014/main" id="{E974662D-C55A-DCBE-DC4D-B01679C55403}"/>
+              </a:ext>
+            </a:extLst>
+          </p:cNvPr>
+          <p:cNvSpPr txBox="1"/>
+          <p:nvPr/>
+        </p:nvSpPr>
+        <p:spPr>
+          <a:xfrm>
+            <a:off x="3687536" y="911679"/>
+            <a:ext cx="4010393" cy="523220"/>
+          </a:xfrm>
+          <a:prstGeom prst="rect">
+            <a:avLst/>
+          </a:prstGeom>
+          <a:noFill/>
+        </p:spPr>
+        <p:txBody>
+          <a:bodyPr wrap="none" rtlCol="0">
+            <a:spAutoFit/>
+          </a:bodyPr>
+          <a:lstStyle/>
+          <a:p>
+            <a:r>
+              <a:rPr lang="pt-BR" sz="2800" dirty="0"/>
+              <a:t>Cadastro bem sucedido!</a:t>
+            </a:r>
+          </a:p>
+        </p:txBody>
+      </p:sp>
+    </p:spTree>
+    <p:extLst>
+      <p:ext uri="{BB962C8B-B14F-4D97-AF65-F5344CB8AC3E}">
+        <p14:creationId xmlns:p14="http://schemas.microsoft.com/office/powerpoint/2010/main" val="2301433500"/>
+      </p:ext>
+    </p:extLst>
+  </p:cSld>
+  <p:clrMapOvr>
+    <a:masterClrMapping/>
+  </p:clrMapOvr>
+</p:sld>
+</file>
+
+<file path=ppt/slides/slide9.xml><?xml version="1.0" encoding="utf-8"?>
+<p:sld xmlns:a="http://schemas.openxmlformats.org/drawingml/2006/main" xmlns:r="http://schemas.openxmlformats.org/officeDocument/2006/relationships" xmlns:p="http://schemas.openxmlformats.org/presentationml/2006/main">
+  <p:cSld>
+    <p:spTree>
+      <p:nvGrpSpPr>
+        <p:cNvPr id="1" name="">
+          <a:extLst>
+            <a:ext uri="{FF2B5EF4-FFF2-40B4-BE49-F238E27FC236}">
+              <a16:creationId xmlns:a16="http://schemas.microsoft.com/office/drawing/2014/main" id="{662F6236-E49E-131D-C2F4-8B9164131B81}"/>
+            </a:ext>
+          </a:extLst>
+        </p:cNvPr>
+        <p:cNvGrpSpPr/>
+        <p:nvPr/>
+      </p:nvGrpSpPr>
+      <p:grpSpPr>
+        <a:xfrm>
+          <a:off x="0" y="0"/>
+          <a:ext cx="0" cy="0"/>
+          <a:chOff x="0" y="0"/>
+          <a:chExt cx="0" cy="0"/>
+        </a:xfrm>
+      </p:grpSpPr>
+      <p:pic>
+        <p:nvPicPr>
+          <p:cNvPr id="2" name="Imagem 1">
+            <a:extLst>
+              <a:ext uri="{FF2B5EF4-FFF2-40B4-BE49-F238E27FC236}">
+                <a16:creationId xmlns:a16="http://schemas.microsoft.com/office/drawing/2014/main" id="{A753578F-812D-CFA7-E014-4FA4D7CBE361}"/>
+              </a:ext>
+            </a:extLst>
+          </p:cNvPr>
+          <p:cNvPicPr>
+            <a:picLocks noChangeAspect="1"/>
+          </p:cNvPicPr>
+          <p:nvPr/>
+        </p:nvPicPr>
+        <p:blipFill>
+          <a:blip r:embed="rId2"/>
+          <a:stretch>
+            <a:fillRect/>
+          </a:stretch>
+        </p:blipFill>
+        <p:spPr>
+          <a:xfrm>
+            <a:off x="485225" y="2353944"/>
+            <a:ext cx="11373949" cy="3894456"/>
+          </a:xfrm>
+          <a:prstGeom prst="rect">
+            <a:avLst/>
+          </a:prstGeom>
+        </p:spPr>
+      </p:pic>
+      <p:sp>
+        <p:nvSpPr>
+          <p:cNvPr id="4" name="CaixaDeTexto 3">
+            <a:extLst>
+              <a:ext uri="{FF2B5EF4-FFF2-40B4-BE49-F238E27FC236}">
+                <a16:creationId xmlns:a16="http://schemas.microsoft.com/office/drawing/2014/main" id="{CE01BCAA-C0E4-04D0-6E7C-9A6DD7268D63}"/>
+              </a:ext>
+            </a:extLst>
+          </p:cNvPr>
+          <p:cNvSpPr txBox="1"/>
+          <p:nvPr/>
+        </p:nvSpPr>
+        <p:spPr>
+          <a:xfrm>
+            <a:off x="2340292" y="1092654"/>
+            <a:ext cx="7511415" cy="523220"/>
+          </a:xfrm>
+          <a:prstGeom prst="rect">
+            <a:avLst/>
+          </a:prstGeom>
+          <a:noFill/>
+        </p:spPr>
+        <p:txBody>
+          <a:bodyPr wrap="none" rtlCol="0">
+            <a:spAutoFit/>
+          </a:bodyPr>
+          <a:lstStyle/>
+          <a:p>
+            <a:r>
+              <a:rPr lang="pt-BR" sz="2800" dirty="0"/>
+              <a:t>Tela de listagem de amigos, exclusão, alteração</a:t>
+            </a:r>
+          </a:p>
+        </p:txBody>
+      </p:sp>
+    </p:spTree>
+    <p:extLst>
+      <p:ext uri="{BB962C8B-B14F-4D97-AF65-F5344CB8AC3E}">
+        <p14:creationId xmlns:p14="http://schemas.microsoft.com/office/powerpoint/2010/main" val="3190995898"/>
       </p:ext>
     </p:extLst>
   </p:cSld>

</xml_diff>